<commit_message>
fix: actualizar presentacion final
</commit_message>
<xml_diff>
--- a/presentacion/presentacion_sp500.pptx
+++ b/presentacion/presentacion_sp500.pptx
@@ -4,6 +4,9 @@
   <p:sldMasterIdLst>
     <p:sldMasterId id="2147483648" r:id="rId1"/>
   </p:sldMasterIdLst>
+  <p:notesMasterIdLst>
+    <p:notesMasterId r:id="rId12"/>
+  </p:notesMasterIdLst>
   <p:sldIdLst>
     <p:sldId id="256" r:id="rId2"/>
     <p:sldId id="257" r:id="rId3"/>
@@ -16,10 +19,7 @@
     <p:sldId id="264" r:id="rId10"/>
     <p:sldId id="265" r:id="rId11"/>
   </p:sldIdLst>
-  <p:notesMasterIdLst>
-    <p:notesMasterId r:id="rId12"/>
-  </p:notesMasterIdLst>
-  <p:sldSz cx="9144000" cy="5143500"/>
+  <p:sldSz cx="9144000" cy="5143500" type="screen16x9"/>
   <p:notesSz cx="5143500" cy="9144000"/>
   <p:defaultTextStyle>
     <a:lvl1pPr marL="0" algn="l" defTabSz="914400" rtl="0" eaLnBrk="1" latinLnBrk="0" hangingPunct="1">
@@ -113,6 +113,11 @@
       </a:defRPr>
     </a:lvl9pPr>
   </p:defaultTextStyle>
+  <p:extLst>
+    <p:ext uri="{EFAFB233-063F-42B5-8137-9DF3F51BA10A}">
+      <p15:sldGuideLst xmlns:p15="http://schemas.microsoft.com/office/powerpoint/2012/main"/>
+    </p:ext>
+  </p:extLst>
 </p:presentation>
 </file>
 
@@ -138,234 +143,10 @@
           <a:chExt cx="0" cy="0"/>
         </a:xfrm>
       </p:grpSpPr>
-      <p:sp>
-        <p:nvSpPr>
-          <p:cNvPr id="2" name="Header Placeholder 1"/>
-          <p:cNvSpPr>
-            <a:spLocks noGrp="1"/>
-          </p:cNvSpPr>
-          <p:nvPr>
-            <p:ph type="hdr" sz="quarter"/>
-          </p:nvPr>
-        </p:nvSpPr>
-        <p:spPr>
-          <a:xfrm>
-            <a:off x="0" y="0"/>
-            <a:ext cx="2971800" cy="458788"/>
-          </a:xfrm>
-          <a:prstGeom prst="rect">
-            <a:avLst/>
-          </a:prstGeom>
-        </p:spPr>
-        <p:txBody>
-          <a:bodyPr vert="horz" lIns="91440" tIns="45720" rIns="91440" bIns="45720" rtlCol="0"/>
-          <a:lstStyle>
-            <a:lvl1pPr algn="l">
-              <a:defRPr sz="1200"/>
-            </a:lvl1pPr>
-          </a:lstStyle>
-          <a:p>
-            <a:endParaRPr lang="en-US"/>
-          </a:p>
-        </p:txBody>
-      </p:sp>
-      <p:sp>
-        <p:nvSpPr>
-          <p:cNvPr id="3" name="Date Placeholder 2"/>
-          <p:cNvSpPr>
-            <a:spLocks noGrp="1"/>
-          </p:cNvSpPr>
-          <p:nvPr>
-            <p:ph type="dt" idx="1"/>
-          </p:nvPr>
-        </p:nvSpPr>
-        <p:spPr>
-          <a:xfrm>
-            <a:off x="3884613" y="0"/>
-            <a:ext cx="2971800" cy="458788"/>
-          </a:xfrm>
-          <a:prstGeom prst="rect">
-            <a:avLst/>
-          </a:prstGeom>
-        </p:spPr>
-        <p:txBody>
-          <a:bodyPr vert="horz" lIns="91440" tIns="45720" rIns="91440" bIns="45720" rtlCol="0"/>
-          <a:lstStyle>
-            <a:lvl1pPr algn="r">
-              <a:defRPr sz="1200"/>
-            </a:lvl1pPr>
-          </a:lstStyle>
-          <a:p>
-            <a:fld id="{5282F153-3F37-0F45-9E97-73ACFA13230C}" type="datetimeFigureOut">
-              <a:rPr lang="en-US"/>
-              <a:t>7/23/19</a:t>
-            </a:fld>
-            <a:endParaRPr lang="en-US"/>
-          </a:p>
-        </p:txBody>
-      </p:sp>
-      <p:sp>
-        <p:nvSpPr>
-          <p:cNvPr id="4" name="Slide Image Placeholder 3"/>
-          <p:cNvSpPr>
-            <a:spLocks noGrp="1" noRot="1" noChangeAspect="1"/>
-          </p:cNvSpPr>
-          <p:nvPr>
-            <p:ph type="sldImg" idx="2"/>
-          </p:nvPr>
-        </p:nvSpPr>
-        <p:spPr>
-          <a:xfrm>
-            <a:off x="685800" y="1143000"/>
-            <a:ext cx="5486400" cy="3086100"/>
-          </a:xfrm>
-          <a:prstGeom prst="rect">
-            <a:avLst/>
-          </a:prstGeom>
-          <a:noFill/>
-          <a:ln w="12700">
-            <a:solidFill>
-              <a:prstClr val="black"/>
-            </a:solidFill>
-          </a:ln>
-        </p:spPr>
-        <p:txBody>
-          <a:bodyPr vert="horz" lIns="91440" tIns="45720" rIns="91440" bIns="45720" rtlCol="0" anchor="ctr"/>
-          <a:lstStyle/>
-          <a:p>
-            <a:endParaRPr lang="en-US"/>
-          </a:p>
-        </p:txBody>
-      </p:sp>
-      <p:sp>
-        <p:nvSpPr>
-          <p:cNvPr id="5" name="Notes Placeholder 4"/>
-          <p:cNvSpPr>
-            <a:spLocks noGrp="1"/>
-          </p:cNvSpPr>
-          <p:nvPr>
-            <p:ph type="body" sz="quarter" idx="3"/>
-          </p:nvPr>
-        </p:nvSpPr>
-        <p:spPr>
-          <a:xfrm>
-            <a:off x="685800" y="4400550"/>
-            <a:ext cx="5486400" cy="3600450"/>
-          </a:xfrm>
-          <a:prstGeom prst="rect">
-            <a:avLst/>
-          </a:prstGeom>
-        </p:spPr>
-        <p:txBody>
-          <a:bodyPr vert="horz" lIns="91440" tIns="45720" rIns="91440" bIns="45720" rtlCol="0"/>
-          <a:lstStyle/>
-          <a:p>
-            <a:pPr lvl="0"/>
-            <a:r>
-              <a:rPr lang="en-US"/>
-              <a:t>Click to edit Master text styles</a:t>
-            </a:r>
-          </a:p>
-          <a:p>
-            <a:pPr lvl="1"/>
-            <a:r>
-              <a:rPr lang="en-US"/>
-              <a:t>Second level</a:t>
-            </a:r>
-          </a:p>
-          <a:p>
-            <a:pPr lvl="2"/>
-            <a:r>
-              <a:rPr lang="en-US"/>
-              <a:t>Third level</a:t>
-            </a:r>
-          </a:p>
-          <a:p>
-            <a:pPr lvl="3"/>
-            <a:r>
-              <a:rPr lang="en-US"/>
-              <a:t>Fourth level</a:t>
-            </a:r>
-          </a:p>
-          <a:p>
-            <a:pPr lvl="4"/>
-            <a:r>
-              <a:rPr lang="en-US"/>
-              <a:t>Fifth level</a:t>
-            </a:r>
-          </a:p>
-        </p:txBody>
-      </p:sp>
-      <p:sp>
-        <p:nvSpPr>
-          <p:cNvPr id="6" name="Footer Placeholder 5"/>
-          <p:cNvSpPr>
-            <a:spLocks noGrp="1"/>
-          </p:cNvSpPr>
-          <p:nvPr>
-            <p:ph type="ftr" sz="quarter" idx="4"/>
-          </p:nvPr>
-        </p:nvSpPr>
-        <p:spPr>
-          <a:xfrm>
-            <a:off x="0" y="8685213"/>
-            <a:ext cx="2971800" cy="458787"/>
-          </a:xfrm>
-          <a:prstGeom prst="rect">
-            <a:avLst/>
-          </a:prstGeom>
-        </p:spPr>
-        <p:txBody>
-          <a:bodyPr vert="horz" lIns="91440" tIns="45720" rIns="91440" bIns="45720" rtlCol="0" anchor="b"/>
-          <a:lstStyle>
-            <a:lvl1pPr algn="l">
-              <a:defRPr sz="1200"/>
-            </a:lvl1pPr>
-          </a:lstStyle>
-          <a:p>
-            <a:endParaRPr lang="en-US"/>
-          </a:p>
-        </p:txBody>
-      </p:sp>
-      <p:sp>
-        <p:nvSpPr>
-          <p:cNvPr id="7" name="Slide Number Placeholder 6"/>
-          <p:cNvSpPr>
-            <a:spLocks noGrp="1"/>
-          </p:cNvSpPr>
-          <p:nvPr>
-            <p:ph type="sldNum" sz="quarter" idx="5"/>
-          </p:nvPr>
-        </p:nvSpPr>
-        <p:spPr>
-          <a:xfrm>
-            <a:off x="3884613" y="8685213"/>
-            <a:ext cx="2971800" cy="458787"/>
-          </a:xfrm>
-          <a:prstGeom prst="rect">
-            <a:avLst/>
-          </a:prstGeom>
-        </p:spPr>
-        <p:txBody>
-          <a:bodyPr vert="horz" lIns="91440" tIns="45720" rIns="91440" bIns="45720" rtlCol="0" anchor="b"/>
-          <a:lstStyle>
-            <a:lvl1pPr algn="r">
-              <a:defRPr sz="1200"/>
-            </a:lvl1pPr>
-          </a:lstStyle>
-          <a:p>
-            <a:fld id="{CE5E9CC1-C706-0F49-92D6-E571CC5EEA8F}" type="slidenum">
-              <a:rPr lang="en-US"/>
-              <a:t>‹#›</a:t>
-            </a:fld>
-            <a:endParaRPr lang="en-US"/>
-          </a:p>
-        </p:txBody>
-      </p:sp>
     </p:spTree>
     <p:extLst>
       <p:ext uri="{BB962C8B-B14F-4D97-AF65-F5344CB8AC3E}">
-        <p14:creationId xmlns:p14="http://schemas.microsoft.com/office/powerpoint/2010/main" val="1024086991"/>
+        <p14:creationId xmlns:p14="http://schemas.microsoft.com/office/powerpoint/2010/main" val="3760501558"/>
       </p:ext>
     </p:extLst>
   </p:cSld>
@@ -513,7 +294,6 @@
               <a:rPr lang="en-US" dirty="0"/>
               <a:t>Introducción: problema, objetivo y herramientas usadas. 2 minutos.</a:t>
             </a:r>
-            <a:endParaRPr lang="en-US" dirty="0"/>
           </a:p>
         </p:txBody>
       </p:sp>
@@ -601,7 +381,6 @@
               <a:rPr lang="en-US" dirty="0"/>
               <a:t>Cerrar con los 3 hallazgos clave y los próximos pasos. Mencionar el repositorio GitHub.</a:t>
             </a:r>
-            <a:endParaRPr lang="en-US" dirty="0"/>
           </a:p>
         </p:txBody>
       </p:sp>
@@ -689,7 +468,6 @@
               <a:rPr lang="en-US" dirty="0"/>
               <a:t>Explicar las 4 preguntas de negocio. Mencionar los datasets de Kaggle.</a:t>
             </a:r>
-            <a:endParaRPr lang="en-US" dirty="0"/>
           </a:p>
         </p:txBody>
       </p:sp>
@@ -777,7 +555,6 @@
               <a:rPr lang="en-US" dirty="0"/>
               <a:t>Describir el pipeline completo en 1 minuto. Énfasis en que es un ciclo analítico de principio a fin.</a:t>
             </a:r>
-            <a:endParaRPr lang="en-US" dirty="0"/>
           </a:p>
         </p:txBody>
       </p:sp>
@@ -865,7 +642,6 @@
               <a:rPr lang="en-US" dirty="0"/>
               <a:t>Señalar que la mayoría de empresas se concentra en valores moderados. El Revenue Growth tiene la mayor dispersión.</a:t>
             </a:r>
-            <a:endParaRPr lang="en-US" dirty="0"/>
           </a:p>
         </p:txBody>
       </p:sp>
@@ -953,7 +729,6 @@
               <a:rPr lang="en-US" dirty="0"/>
               <a:t>La independencia entre KPIs justifica usarlos todos en PCA y K-Means sin riesgo de multicolinealidad.</a:t>
             </a:r>
-            <a:endParaRPr lang="en-US" dirty="0"/>
           </a:p>
         </p:txBody>
       </p:sp>
@@ -1041,7 +816,6 @@
               <a:rPr lang="en-US" dirty="0"/>
               <a:t>El método del codo justifica k=4. Coincidencia con los 4 sectores es un argumento adicional.</a:t>
             </a:r>
-            <a:endParaRPr lang="en-US" dirty="0"/>
           </a:p>
         </p:txBody>
       </p:sp>
@@ -1129,7 +903,6 @@
               <a:rPr lang="en-US" dirty="0"/>
               <a:t>El Cluster 2 es el ganador: margen 37%, crecimiento 94%, deuda moderada. Solo 20 empresas.</a:t>
             </a:r>
-            <a:endParaRPr lang="en-US" dirty="0"/>
           </a:p>
         </p:txBody>
       </p:sp>
@@ -1217,7 +990,6 @@
               <a:rPr lang="en-US" dirty="0"/>
               <a:t>Mostrar la tabla y el circular. Healthcare lidera con 30%, seguido de Technology 26%, Energy 25% y Basic Materials 18%.</a:t>
             </a:r>
-            <a:endParaRPr lang="en-US" dirty="0"/>
           </a:p>
         </p:txBody>
       </p:sp>
@@ -1305,7 +1077,6 @@
               <a:rPr lang="en-US" dirty="0"/>
               <a:t>Explicar el gráfico de dispersión: eje X = deuda, eje Y = margen, tamaño = inversión. Zona ideal = arriba a la izquierda.</a:t>
             </a:r>
-            <a:endParaRPr lang="en-US" dirty="0"/>
           </a:p>
         </p:txBody>
       </p:sp>
@@ -1378,6 +1149,11 @@
 <file path=ppt/slideMasters/slideMaster1.xml><?xml version="1.0" encoding="utf-8"?>
 <p:sldMaster xmlns:a="http://schemas.openxmlformats.org/drawingml/2006/main" xmlns:r="http://schemas.openxmlformats.org/officeDocument/2006/relationships" xmlns:p="http://schemas.openxmlformats.org/presentationml/2006/main">
   <p:cSld>
+    <p:bg>
+      <p:bgRef idx="1001">
+        <a:schemeClr val="bg1"/>
+      </p:bgRef>
+    </p:bg>
     <p:spTree>
       <p:nvGrpSpPr>
         <p:cNvPr id="1" name=""/>
@@ -1660,6 +1436,7 @@
         <a:solidFill>
           <a:srgbClr val="1E2761"/>
         </a:solidFill>
+        <a:effectLst/>
       </p:bgPr>
     </p:bg>
     <p:spTree>
@@ -1704,6 +1481,13 @@
             <a:prstDash val="solid"/>
           </a:ln>
         </p:spPr>
+        <p:txBody>
+          <a:bodyPr/>
+          <a:lstStyle/>
+          <a:p>
+            <a:endParaRPr lang="es-ES"/>
+          </a:p>
+        </p:txBody>
       </p:sp>
       <p:sp>
         <p:nvSpPr>
@@ -1726,7 +1510,7 @@
           <a:bodyPr wrap="square" rtlCol="0" anchor="ctr"/>
           <a:lstStyle/>
           <a:p>
-            <a:pPr algn="ctr" indent="0" marL="0">
+            <a:pPr marL="0" indent="0" algn="ctr">
               <a:buNone/>
             </a:pPr>
             <a:r>
@@ -1765,7 +1549,7 @@
           <a:bodyPr wrap="square" rtlCol="0" anchor="ctr"/>
           <a:lstStyle/>
           <a:p>
-            <a:pPr algn="ctr" indent="0" marL="0">
+            <a:pPr marL="0" indent="0" algn="ctr">
               <a:buNone/>
             </a:pPr>
             <a:r>
@@ -1782,7 +1566,7 @@
             <a:endParaRPr lang="en-US" sz="3200" dirty="0"/>
           </a:p>
           <a:p>
-            <a:pPr algn="ctr" indent="0" marL="0">
+            <a:pPr marL="0" indent="0" algn="ctr">
               <a:buNone/>
             </a:pPr>
             <a:r>
@@ -1821,7 +1605,7 @@
           <a:bodyPr wrap="square" rtlCol="0" anchor="ctr"/>
           <a:lstStyle/>
           <a:p>
-            <a:pPr algn="ctr" indent="0" marL="0">
+            <a:pPr marL="0" indent="0" algn="ctr">
               <a:buNone/>
             </a:pPr>
             <a:r>
@@ -1860,7 +1644,7 @@
           <a:bodyPr wrap="square" rtlCol="0" anchor="ctr"/>
           <a:lstStyle/>
           <a:p>
-            <a:pPr algn="ctr" indent="0" marL="0">
+            <a:pPr marL="0" indent="0" algn="ctr">
               <a:buNone/>
             </a:pPr>
             <a:r>
@@ -1894,6 +1678,7 @@
         <a:solidFill>
           <a:srgbClr val="1E2761"/>
         </a:solidFill>
+        <a:effectLst/>
       </p:bgPr>
     </p:bg>
     <p:spTree>
@@ -1931,7 +1716,7 @@
           <a:bodyPr wrap="square" rtlCol="0" anchor="ctr"/>
           <a:lstStyle/>
           <a:p>
-            <a:pPr indent="0" marL="0">
+            <a:pPr marL="0" indent="0">
               <a:buNone/>
             </a:pPr>
             <a:r>
@@ -1977,6 +1762,13 @@
             <a:prstDash val="solid"/>
           </a:ln>
         </p:spPr>
+        <p:txBody>
+          <a:bodyPr/>
+          <a:lstStyle/>
+          <a:p>
+            <a:endParaRPr lang="es-ES"/>
+          </a:p>
+        </p:txBody>
       </p:sp>
       <p:sp>
         <p:nvSpPr>
@@ -1999,7 +1791,7 @@
           <a:bodyPr wrap="square" rtlCol="0" anchor="ctr"/>
           <a:lstStyle/>
           <a:p>
-            <a:pPr algn="ctr" indent="0" marL="0">
+            <a:pPr marL="0" indent="0" algn="ctr">
               <a:buNone/>
             </a:pPr>
             <a:r>
@@ -2038,7 +1830,7 @@
           <a:bodyPr wrap="square" rtlCol="0" anchor="ctr"/>
           <a:lstStyle/>
           <a:p>
-            <a:pPr algn="ctr" indent="0" marL="0">
+            <a:pPr marL="0" indent="0" algn="ctr">
               <a:buNone/>
             </a:pPr>
             <a:r>
@@ -2055,7 +1847,7 @@
             <a:endParaRPr lang="en-US" sz="1100" dirty="0"/>
           </a:p>
           <a:p>
-            <a:pPr algn="ctr" indent="0" marL="0">
+            <a:pPr marL="0" indent="0" algn="ctr">
               <a:buNone/>
             </a:pPr>
             <a:r>
@@ -2101,6 +1893,13 @@
             <a:prstDash val="solid"/>
           </a:ln>
         </p:spPr>
+        <p:txBody>
+          <a:bodyPr/>
+          <a:lstStyle/>
+          <a:p>
+            <a:endParaRPr lang="es-ES"/>
+          </a:p>
+        </p:txBody>
       </p:sp>
       <p:sp>
         <p:nvSpPr>
@@ -2123,7 +1922,7 @@
           <a:bodyPr wrap="square" rtlCol="0" anchor="ctr"/>
           <a:lstStyle/>
           <a:p>
-            <a:pPr algn="ctr" indent="0" marL="0">
+            <a:pPr marL="0" indent="0" algn="ctr">
               <a:buNone/>
             </a:pPr>
             <a:r>
@@ -2162,7 +1961,7 @@
           <a:bodyPr wrap="square" rtlCol="0" anchor="ctr"/>
           <a:lstStyle/>
           <a:p>
-            <a:pPr algn="ctr" indent="0" marL="0">
+            <a:pPr marL="0" indent="0" algn="ctr">
               <a:buNone/>
             </a:pPr>
             <a:r>
@@ -2179,7 +1978,7 @@
             <a:endParaRPr lang="en-US" sz="1100" dirty="0"/>
           </a:p>
           <a:p>
-            <a:pPr algn="ctr" indent="0" marL="0">
+            <a:pPr marL="0" indent="0" algn="ctr">
               <a:buNone/>
             </a:pPr>
             <a:r>
@@ -2225,6 +2024,13 @@
             <a:prstDash val="solid"/>
           </a:ln>
         </p:spPr>
+        <p:txBody>
+          <a:bodyPr/>
+          <a:lstStyle/>
+          <a:p>
+            <a:endParaRPr lang="es-ES"/>
+          </a:p>
+        </p:txBody>
       </p:sp>
       <p:sp>
         <p:nvSpPr>
@@ -2247,7 +2053,7 @@
           <a:bodyPr wrap="square" rtlCol="0" anchor="ctr"/>
           <a:lstStyle/>
           <a:p>
-            <a:pPr algn="ctr" indent="0" marL="0">
+            <a:pPr marL="0" indent="0" algn="ctr">
               <a:buNone/>
             </a:pPr>
             <a:r>
@@ -2286,7 +2092,7 @@
           <a:bodyPr wrap="square" rtlCol="0" anchor="ctr"/>
           <a:lstStyle/>
           <a:p>
-            <a:pPr algn="ctr" indent="0" marL="0">
+            <a:pPr marL="0" indent="0" algn="ctr">
               <a:buNone/>
             </a:pPr>
             <a:r>
@@ -2303,7 +2109,7 @@
             <a:endParaRPr lang="en-US" sz="1100" dirty="0"/>
           </a:p>
           <a:p>
-            <a:pPr algn="ctr" indent="0" marL="0">
+            <a:pPr marL="0" indent="0" algn="ctr">
               <a:buNone/>
             </a:pPr>
             <a:r>
@@ -2349,6 +2155,13 @@
             <a:prstDash val="solid"/>
           </a:ln>
         </p:spPr>
+        <p:txBody>
+          <a:bodyPr/>
+          <a:lstStyle/>
+          <a:p>
+            <a:endParaRPr lang="es-ES"/>
+          </a:p>
+        </p:txBody>
       </p:sp>
       <p:sp>
         <p:nvSpPr>
@@ -2371,7 +2184,7 @@
           <a:bodyPr wrap="square" rtlCol="0" anchor="ctr"/>
           <a:lstStyle/>
           <a:p>
-            <a:pPr algn="ctr" indent="0" marL="0">
+            <a:pPr marL="0" indent="0" algn="ctr">
               <a:buNone/>
             </a:pPr>
             <a:r>
@@ -2410,7 +2223,7 @@
           <a:bodyPr wrap="square" rtlCol="0" anchor="ctr"/>
           <a:lstStyle/>
           <a:p>
-            <a:pPr algn="ctr" indent="0" marL="0">
+            <a:pPr marL="0" indent="0" algn="ctr">
               <a:buNone/>
             </a:pPr>
             <a:r>
@@ -2427,7 +2240,7 @@
             <a:endParaRPr lang="en-US" sz="1100" dirty="0"/>
           </a:p>
           <a:p>
-            <a:pPr algn="ctr" indent="0" marL="0">
+            <a:pPr marL="0" indent="0" algn="ctr">
               <a:buNone/>
             </a:pPr>
             <a:r>
@@ -2466,7 +2279,7 @@
           <a:bodyPr wrap="square" rtlCol="0" anchor="ctr"/>
           <a:lstStyle/>
           <a:p>
-            <a:pPr indent="0" marL="0">
+            <a:pPr marL="0" indent="0">
               <a:buNone/>
             </a:pPr>
             <a:r>
@@ -2590,7 +2403,7 @@
           <a:bodyPr wrap="square" rtlCol="0" anchor="ctr"/>
           <a:lstStyle/>
           <a:p>
-            <a:pPr indent="0" marL="0">
+            <a:pPr marL="0" indent="0">
               <a:buNone/>
             </a:pPr>
             <a:r>
@@ -2714,7 +2527,7 @@
           <a:bodyPr wrap="square" rtlCol="0" anchor="ctr"/>
           <a:lstStyle/>
           <a:p>
-            <a:pPr algn="ctr" indent="0" marL="0">
+            <a:pPr marL="0" indent="0" algn="ctr">
               <a:buNone/>
             </a:pPr>
             <a:r>
@@ -2748,6 +2561,7 @@
         <a:solidFill>
           <a:srgbClr val="F4F6FB"/>
         </a:solidFill>
+        <a:effectLst/>
       </p:bgPr>
     </p:bg>
     <p:spTree>
@@ -2785,7 +2599,7 @@
           <a:bodyPr wrap="square" rtlCol="0" anchor="ctr"/>
           <a:lstStyle/>
           <a:p>
-            <a:pPr indent="0" marL="0">
+            <a:pPr marL="0" indent="0">
               <a:buNone/>
             </a:pPr>
             <a:r>
@@ -2824,13 +2638,20 @@
           </a:solidFill>
           <a:ln/>
           <a:effectLst>
-            <a:outerShdw sx="100000" sy="100000" kx="0" ky="0" algn="bl" rotWithShape="0" blurRad="101600" dist="38100" dir="2700000">
+            <a:outerShdw blurRad="101600" dist="38100" dir="2700000" algn="bl" rotWithShape="0">
               <a:srgbClr val="000000">
                 <a:alpha val="12000"/>
               </a:srgbClr>
             </a:outerShdw>
           </a:effectLst>
         </p:spPr>
+        <p:txBody>
+          <a:bodyPr/>
+          <a:lstStyle/>
+          <a:p>
+            <a:endParaRPr lang="es-ES"/>
+          </a:p>
+        </p:txBody>
       </p:sp>
       <p:sp>
         <p:nvSpPr>
@@ -2853,7 +2674,7 @@
           <a:bodyPr wrap="square" rtlCol="0" anchor="ctr"/>
           <a:lstStyle/>
           <a:p>
-            <a:pPr algn="ctr" indent="0" marL="0">
+            <a:pPr marL="0" indent="0" algn="ctr">
               <a:buNone/>
             </a:pPr>
             <a:r>
@@ -2892,13 +2713,20 @@
           </a:solidFill>
           <a:ln/>
           <a:effectLst>
-            <a:outerShdw sx="100000" sy="100000" kx="0" ky="0" algn="bl" rotWithShape="0" blurRad="101600" dist="38100" dir="2700000">
+            <a:outerShdw blurRad="101600" dist="38100" dir="2700000" algn="bl" rotWithShape="0">
               <a:srgbClr val="000000">
                 <a:alpha val="12000"/>
               </a:srgbClr>
             </a:outerShdw>
           </a:effectLst>
         </p:spPr>
+        <p:txBody>
+          <a:bodyPr/>
+          <a:lstStyle/>
+          <a:p>
+            <a:endParaRPr lang="es-ES"/>
+          </a:p>
+        </p:txBody>
       </p:sp>
       <p:sp>
         <p:nvSpPr>
@@ -2921,7 +2749,7 @@
           <a:bodyPr wrap="square" rtlCol="0" anchor="ctr"/>
           <a:lstStyle/>
           <a:p>
-            <a:pPr algn="ctr" indent="0" marL="0">
+            <a:pPr marL="0" indent="0" algn="ctr">
               <a:buNone/>
             </a:pPr>
             <a:r>
@@ -2938,7 +2766,7 @@
             <a:endParaRPr lang="en-US" sz="1300" dirty="0"/>
           </a:p>
           <a:p>
-            <a:pPr algn="ctr" indent="0" marL="0">
+            <a:pPr marL="0" indent="0" algn="ctr">
               <a:buNone/>
             </a:pPr>
             <a:r>
@@ -2977,13 +2805,20 @@
           </a:solidFill>
           <a:ln/>
           <a:effectLst>
-            <a:outerShdw sx="100000" sy="100000" kx="0" ky="0" algn="bl" rotWithShape="0" blurRad="101600" dist="38100" dir="2700000">
+            <a:outerShdw blurRad="101600" dist="38100" dir="2700000" algn="bl" rotWithShape="0">
               <a:srgbClr val="000000">
                 <a:alpha val="12000"/>
               </a:srgbClr>
             </a:outerShdw>
           </a:effectLst>
         </p:spPr>
+        <p:txBody>
+          <a:bodyPr/>
+          <a:lstStyle/>
+          <a:p>
+            <a:endParaRPr lang="es-ES"/>
+          </a:p>
+        </p:txBody>
       </p:sp>
       <p:sp>
         <p:nvSpPr>
@@ -3006,7 +2841,7 @@
           <a:bodyPr wrap="square" rtlCol="0" anchor="ctr"/>
           <a:lstStyle/>
           <a:p>
-            <a:pPr algn="ctr" indent="0" marL="0">
+            <a:pPr marL="0" indent="0" algn="ctr">
               <a:buNone/>
             </a:pPr>
             <a:r>
@@ -3023,7 +2858,7 @@
             <a:endParaRPr lang="en-US" sz="1300" dirty="0"/>
           </a:p>
           <a:p>
-            <a:pPr algn="ctr" indent="0" marL="0">
+            <a:pPr marL="0" indent="0" algn="ctr">
               <a:buNone/>
             </a:pPr>
             <a:r>
@@ -3062,13 +2897,20 @@
           </a:solidFill>
           <a:ln/>
           <a:effectLst>
-            <a:outerShdw sx="100000" sy="100000" kx="0" ky="0" algn="bl" rotWithShape="0" blurRad="101600" dist="38100" dir="2700000">
+            <a:outerShdw blurRad="101600" dist="38100" dir="2700000" algn="bl" rotWithShape="0">
               <a:srgbClr val="000000">
                 <a:alpha val="12000"/>
               </a:srgbClr>
             </a:outerShdw>
           </a:effectLst>
         </p:spPr>
+        <p:txBody>
+          <a:bodyPr/>
+          <a:lstStyle/>
+          <a:p>
+            <a:endParaRPr lang="es-ES"/>
+          </a:p>
+        </p:txBody>
       </p:sp>
       <p:sp>
         <p:nvSpPr>
@@ -3091,7 +2933,7 @@
           <a:bodyPr wrap="square" rtlCol="0" anchor="ctr"/>
           <a:lstStyle/>
           <a:p>
-            <a:pPr algn="ctr" indent="0" marL="0">
+            <a:pPr marL="0" indent="0" algn="ctr">
               <a:buNone/>
             </a:pPr>
             <a:r>
@@ -3108,7 +2950,7 @@
             <a:endParaRPr lang="en-US" sz="1300" dirty="0"/>
           </a:p>
           <a:p>
-            <a:pPr algn="ctr" indent="0" marL="0">
+            <a:pPr marL="0" indent="0" algn="ctr">
               <a:buNone/>
             </a:pPr>
             <a:r>
@@ -3147,13 +2989,20 @@
           </a:solidFill>
           <a:ln/>
           <a:effectLst>
-            <a:outerShdw sx="100000" sy="100000" kx="0" ky="0" algn="bl" rotWithShape="0" blurRad="101600" dist="38100" dir="2700000">
+            <a:outerShdw blurRad="101600" dist="38100" dir="2700000" algn="bl" rotWithShape="0">
               <a:srgbClr val="000000">
                 <a:alpha val="12000"/>
               </a:srgbClr>
             </a:outerShdw>
           </a:effectLst>
         </p:spPr>
+        <p:txBody>
+          <a:bodyPr/>
+          <a:lstStyle/>
+          <a:p>
+            <a:endParaRPr lang="es-ES"/>
+          </a:p>
+        </p:txBody>
       </p:sp>
       <p:sp>
         <p:nvSpPr>
@@ -3176,7 +3025,7 @@
           <a:bodyPr wrap="square" rtlCol="0" anchor="ctr"/>
           <a:lstStyle/>
           <a:p>
-            <a:pPr algn="ctr" indent="0" marL="0">
+            <a:pPr marL="0" indent="0" algn="ctr">
               <a:buNone/>
             </a:pPr>
             <a:r>
@@ -3193,7 +3042,7 @@
             <a:endParaRPr lang="en-US" sz="1300" dirty="0"/>
           </a:p>
           <a:p>
-            <a:pPr algn="ctr" indent="0" marL="0">
+            <a:pPr marL="0" indent="0" algn="ctr">
               <a:buNone/>
             </a:pPr>
             <a:r>
@@ -3232,7 +3081,7 @@
           <a:bodyPr wrap="square" rtlCol="0" anchor="ctr"/>
           <a:lstStyle/>
           <a:p>
-            <a:pPr algn="ctr" indent="0" marL="0">
+            <a:pPr marL="0" indent="0" algn="ctr">
               <a:buNone/>
             </a:pPr>
             <a:r>
@@ -3266,6 +3115,7 @@
         <a:solidFill>
           <a:srgbClr val="F4F6FB"/>
         </a:solidFill>
+        <a:effectLst/>
       </p:bgPr>
     </p:bg>
     <p:spTree>
@@ -3303,7 +3153,7 @@
           <a:bodyPr wrap="square" rtlCol="0" anchor="ctr"/>
           <a:lstStyle/>
           <a:p>
-            <a:pPr indent="0" marL="0">
+            <a:pPr marL="0" indent="0">
               <a:buNone/>
             </a:pPr>
             <a:r>
@@ -3342,13 +3192,20 @@
           </a:solidFill>
           <a:ln/>
           <a:effectLst>
-            <a:outerShdw sx="100000" sy="100000" kx="0" ky="0" algn="bl" rotWithShape="0" blurRad="101600" dist="38100" dir="2700000">
+            <a:outerShdw blurRad="101600" dist="38100" dir="2700000" algn="bl" rotWithShape="0">
               <a:srgbClr val="000000">
                 <a:alpha val="12000"/>
               </a:srgbClr>
             </a:outerShdw>
           </a:effectLst>
         </p:spPr>
+        <p:txBody>
+          <a:bodyPr/>
+          <a:lstStyle/>
+          <a:p>
+            <a:endParaRPr lang="es-ES"/>
+          </a:p>
+        </p:txBody>
       </p:sp>
       <p:sp>
         <p:nvSpPr>
@@ -3371,7 +3228,7 @@
           <a:bodyPr wrap="square" rtlCol="0" anchor="ctr"/>
           <a:lstStyle/>
           <a:p>
-            <a:pPr algn="ctr" indent="0" marL="0">
+            <a:pPr marL="0" indent="0" algn="ctr">
               <a:buNone/>
             </a:pPr>
             <a:r>
@@ -3410,7 +3267,7 @@
           <a:bodyPr wrap="square" rtlCol="0" anchor="ctr"/>
           <a:lstStyle/>
           <a:p>
-            <a:pPr algn="ctr" indent="0" marL="0">
+            <a:pPr marL="0" indent="0" algn="ctr">
               <a:buNone/>
             </a:pPr>
             <a:r>
@@ -3427,7 +3284,7 @@
             <a:endParaRPr lang="en-US" sz="1400" dirty="0"/>
           </a:p>
           <a:p>
-            <a:pPr algn="ctr" indent="0" marL="0">
+            <a:pPr marL="0" indent="0" algn="ctr">
               <a:buNone/>
             </a:pPr>
             <a:r>
@@ -3466,7 +3323,7 @@
           <a:bodyPr wrap="square" rtlCol="0" anchor="ctr"/>
           <a:lstStyle/>
           <a:p>
-            <a:pPr algn="ctr" indent="0" marL="0">
+            <a:pPr marL="0" indent="0" algn="ctr">
               <a:buNone/>
             </a:pPr>
             <a:r>
@@ -3478,7 +3335,7 @@
                 <a:ea typeface="Calibri" pitchFamily="34" charset="-122"/>
                 <a:cs typeface="Calibri" pitchFamily="34" charset="-120"/>
               </a:rPr>
-              <a:t>3.808 → 242</a:t>
+              <a:t>3.808 → 1.124</a:t>
             </a:r>
             <a:endParaRPr lang="en-US" sz="1100" dirty="0"/>
           </a:p>
@@ -3505,7 +3362,7 @@
           <a:bodyPr wrap="square" rtlCol="0" anchor="ctr"/>
           <a:lstStyle/>
           <a:p>
-            <a:pPr algn="ctr" indent="0" marL="0">
+            <a:pPr marL="0" indent="0" algn="ctr">
               <a:buNone/>
             </a:pPr>
             <a:r>
@@ -3544,13 +3401,20 @@
           </a:solidFill>
           <a:ln/>
           <a:effectLst>
-            <a:outerShdw sx="100000" sy="100000" kx="0" ky="0" algn="bl" rotWithShape="0" blurRad="101600" dist="38100" dir="2700000">
+            <a:outerShdw blurRad="101600" dist="38100" dir="2700000" algn="bl" rotWithShape="0">
               <a:srgbClr val="000000">
                 <a:alpha val="12000"/>
               </a:srgbClr>
             </a:outerShdw>
           </a:effectLst>
         </p:spPr>
+        <p:txBody>
+          <a:bodyPr/>
+          <a:lstStyle/>
+          <a:p>
+            <a:endParaRPr lang="es-ES"/>
+          </a:p>
+        </p:txBody>
       </p:sp>
       <p:sp>
         <p:nvSpPr>
@@ -3573,7 +3437,7 @@
           <a:bodyPr wrap="square" rtlCol="0" anchor="ctr"/>
           <a:lstStyle/>
           <a:p>
-            <a:pPr algn="ctr" indent="0" marL="0">
+            <a:pPr marL="0" indent="0" algn="ctr">
               <a:buNone/>
             </a:pPr>
             <a:r>
@@ -3612,7 +3476,7 @@
           <a:bodyPr wrap="square" rtlCol="0" anchor="ctr"/>
           <a:lstStyle/>
           <a:p>
-            <a:pPr algn="ctr" indent="0" marL="0">
+            <a:pPr marL="0" indent="0" algn="ctr">
               <a:buNone/>
             </a:pPr>
             <a:r>
@@ -3629,7 +3493,7 @@
             <a:endParaRPr lang="en-US" sz="1400" dirty="0"/>
           </a:p>
           <a:p>
-            <a:pPr algn="ctr" indent="0" marL="0">
+            <a:pPr marL="0" indent="0" algn="ctr">
               <a:buNone/>
             </a:pPr>
             <a:r>
@@ -3668,7 +3532,7 @@
           <a:bodyPr wrap="square" rtlCol="0" anchor="ctr"/>
           <a:lstStyle/>
           <a:p>
-            <a:pPr algn="ctr" indent="0" marL="0">
+            <a:pPr marL="0" indent="0" algn="ctr">
               <a:buNone/>
             </a:pPr>
             <a:r>
@@ -3707,7 +3571,7 @@
           <a:bodyPr wrap="square" rtlCol="0" anchor="ctr"/>
           <a:lstStyle/>
           <a:p>
-            <a:pPr algn="ctr" indent="0" marL="0">
+            <a:pPr marL="0" indent="0" algn="ctr">
               <a:buNone/>
             </a:pPr>
             <a:r>
@@ -3746,13 +3610,20 @@
           </a:solidFill>
           <a:ln/>
           <a:effectLst>
-            <a:outerShdw sx="100000" sy="100000" kx="0" ky="0" algn="bl" rotWithShape="0" blurRad="101600" dist="38100" dir="2700000">
+            <a:outerShdw blurRad="101600" dist="38100" dir="2700000" algn="bl" rotWithShape="0">
               <a:srgbClr val="000000">
                 <a:alpha val="12000"/>
               </a:srgbClr>
             </a:outerShdw>
           </a:effectLst>
         </p:spPr>
+        <p:txBody>
+          <a:bodyPr/>
+          <a:lstStyle/>
+          <a:p>
+            <a:endParaRPr lang="es-ES"/>
+          </a:p>
+        </p:txBody>
       </p:sp>
       <p:sp>
         <p:nvSpPr>
@@ -3775,7 +3646,7 @@
           <a:bodyPr wrap="square" rtlCol="0" anchor="ctr"/>
           <a:lstStyle/>
           <a:p>
-            <a:pPr algn="ctr" indent="0" marL="0">
+            <a:pPr marL="0" indent="0" algn="ctr">
               <a:buNone/>
             </a:pPr>
             <a:r>
@@ -3814,7 +3685,7 @@
           <a:bodyPr wrap="square" rtlCol="0" anchor="ctr"/>
           <a:lstStyle/>
           <a:p>
-            <a:pPr algn="ctr" indent="0" marL="0">
+            <a:pPr marL="0" indent="0" algn="ctr">
               <a:buNone/>
             </a:pPr>
             <a:r>
@@ -3853,7 +3724,7 @@
           <a:bodyPr wrap="square" rtlCol="0" anchor="ctr"/>
           <a:lstStyle/>
           <a:p>
-            <a:pPr algn="ctr" indent="0" marL="0">
+            <a:pPr marL="0" indent="0" algn="ctr">
               <a:buNone/>
             </a:pPr>
             <a:r>
@@ -3870,7 +3741,7 @@
             <a:endParaRPr lang="en-US" sz="1100" dirty="0"/>
           </a:p>
           <a:p>
-            <a:pPr algn="ctr" indent="0" marL="0">
+            <a:pPr marL="0" indent="0" algn="ctr">
               <a:buNone/>
             </a:pPr>
             <a:r>
@@ -3909,7 +3780,7 @@
           <a:bodyPr wrap="square" rtlCol="0" anchor="ctr"/>
           <a:lstStyle/>
           <a:p>
-            <a:pPr algn="ctr" indent="0" marL="0">
+            <a:pPr marL="0" indent="0" algn="ctr">
               <a:buNone/>
             </a:pPr>
             <a:r>
@@ -3948,13 +3819,20 @@
           </a:solidFill>
           <a:ln/>
           <a:effectLst>
-            <a:outerShdw sx="100000" sy="100000" kx="0" ky="0" algn="bl" rotWithShape="0" blurRad="101600" dist="38100" dir="2700000">
+            <a:outerShdw blurRad="101600" dist="38100" dir="2700000" algn="bl" rotWithShape="0">
               <a:srgbClr val="000000">
                 <a:alpha val="12000"/>
               </a:srgbClr>
             </a:outerShdw>
           </a:effectLst>
         </p:spPr>
+        <p:txBody>
+          <a:bodyPr/>
+          <a:lstStyle/>
+          <a:p>
+            <a:endParaRPr lang="es-ES"/>
+          </a:p>
+        </p:txBody>
       </p:sp>
       <p:sp>
         <p:nvSpPr>
@@ -3977,7 +3855,7 @@
           <a:bodyPr wrap="square" rtlCol="0" anchor="ctr"/>
           <a:lstStyle/>
           <a:p>
-            <a:pPr algn="ctr" indent="0" marL="0">
+            <a:pPr marL="0" indent="0" algn="ctr">
               <a:buNone/>
             </a:pPr>
             <a:r>
@@ -4016,7 +3894,7 @@
           <a:bodyPr wrap="square" rtlCol="0" anchor="ctr"/>
           <a:lstStyle/>
           <a:p>
-            <a:pPr algn="ctr" indent="0" marL="0">
+            <a:pPr marL="0" indent="0" algn="ctr">
               <a:buNone/>
             </a:pPr>
             <a:r>
@@ -4033,7 +3911,7 @@
             <a:endParaRPr lang="en-US" sz="1400" dirty="0"/>
           </a:p>
           <a:p>
-            <a:pPr algn="ctr" indent="0" marL="0">
+            <a:pPr marL="0" indent="0" algn="ctr">
               <a:buNone/>
             </a:pPr>
             <a:r>
@@ -4072,7 +3950,7 @@
           <a:bodyPr wrap="square" rtlCol="0" anchor="ctr"/>
           <a:lstStyle/>
           <a:p>
-            <a:pPr algn="ctr" indent="0" marL="0">
+            <a:pPr marL="0" indent="0" algn="ctr">
               <a:buNone/>
             </a:pPr>
             <a:r>
@@ -4089,7 +3967,7 @@
             <a:endParaRPr lang="en-US" sz="1100" dirty="0"/>
           </a:p>
           <a:p>
-            <a:pPr algn="ctr" indent="0" marL="0">
+            <a:pPr marL="0" indent="0" algn="ctr">
               <a:buNone/>
             </a:pPr>
             <a:r>
@@ -4128,7 +4006,7 @@
           <a:bodyPr wrap="square" rtlCol="0" anchor="ctr"/>
           <a:lstStyle/>
           <a:p>
-            <a:pPr algn="ctr" indent="0" marL="0">
+            <a:pPr marL="0" indent="0" algn="ctr">
               <a:buNone/>
             </a:pPr>
             <a:r>
@@ -4167,13 +4045,20 @@
           </a:solidFill>
           <a:ln/>
           <a:effectLst>
-            <a:outerShdw sx="100000" sy="100000" kx="0" ky="0" algn="bl" rotWithShape="0" blurRad="101600" dist="38100" dir="2700000">
+            <a:outerShdw blurRad="101600" dist="38100" dir="2700000" algn="bl" rotWithShape="0">
               <a:srgbClr val="000000">
                 <a:alpha val="12000"/>
               </a:srgbClr>
             </a:outerShdw>
           </a:effectLst>
         </p:spPr>
+        <p:txBody>
+          <a:bodyPr/>
+          <a:lstStyle/>
+          <a:p>
+            <a:endParaRPr lang="es-ES"/>
+          </a:p>
+        </p:txBody>
       </p:sp>
       <p:sp>
         <p:nvSpPr>
@@ -4196,7 +4081,7 @@
           <a:bodyPr wrap="square" rtlCol="0" anchor="ctr"/>
           <a:lstStyle/>
           <a:p>
-            <a:pPr algn="ctr" indent="0" marL="0">
+            <a:pPr marL="0" indent="0" algn="ctr">
               <a:buNone/>
             </a:pPr>
             <a:r>
@@ -4235,7 +4120,7 @@
           <a:bodyPr wrap="square" rtlCol="0" anchor="ctr"/>
           <a:lstStyle/>
           <a:p>
-            <a:pPr algn="ctr" indent="0" marL="0">
+            <a:pPr marL="0" indent="0" algn="ctr">
               <a:buNone/>
             </a:pPr>
             <a:r>
@@ -4252,7 +4137,7 @@
             <a:endParaRPr lang="en-US" sz="1400" dirty="0"/>
           </a:p>
           <a:p>
-            <a:pPr algn="ctr" indent="0" marL="0">
+            <a:pPr marL="0" indent="0" algn="ctr">
               <a:buNone/>
             </a:pPr>
             <a:r>
@@ -4291,7 +4176,7 @@
           <a:bodyPr wrap="square" rtlCol="0" anchor="ctr"/>
           <a:lstStyle/>
           <a:p>
-            <a:pPr algn="ctr" indent="0" marL="0">
+            <a:pPr marL="0" indent="0" algn="ctr">
               <a:buNone/>
             </a:pPr>
             <a:r>
@@ -4308,7 +4193,7 @@
             <a:endParaRPr lang="en-US" sz="1100" dirty="0"/>
           </a:p>
           <a:p>
-            <a:pPr algn="ctr" indent="0" marL="0">
+            <a:pPr marL="0" indent="0" algn="ctr">
               <a:buNone/>
             </a:pPr>
             <a:r>
@@ -4347,7 +4232,7 @@
           <a:bodyPr wrap="square" rtlCol="0" anchor="ctr"/>
           <a:lstStyle/>
           <a:p>
-            <a:pPr algn="ctr" indent="0" marL="0">
+            <a:pPr marL="0" indent="0" algn="ctr">
               <a:buNone/>
             </a:pPr>
             <a:r>
@@ -4381,6 +4266,7 @@
         <a:solidFill>
           <a:srgbClr val="F4F6FB"/>
         </a:solidFill>
+        <a:effectLst/>
       </p:bgPr>
     </p:bg>
     <p:spTree>
@@ -4418,7 +4304,7 @@
           <a:bodyPr wrap="square" rtlCol="0" anchor="ctr"/>
           <a:lstStyle/>
           <a:p>
-            <a:pPr indent="0" marL="0">
+            <a:pPr marL="0" indent="0">
               <a:buNone/>
             </a:pPr>
             <a:r>
@@ -4438,15 +4324,15 @@
       </p:sp>
       <p:pic>
         <p:nvPicPr>
-          <p:cNvPr id="3" name="Image 0" descr="/home/claude/dist_kpis.png">    </p:cNvPr>
+          <p:cNvPr id="3" name="Image 0" descr="/home/claude/dist_kpis.png"/>
           <p:cNvPicPr>
             <a:picLocks noChangeAspect="1"/>
           </p:cNvPicPr>
           <p:nvPr/>
         </p:nvPicPr>
         <p:blipFill>
-          <a:blip r:embed="rId1"/>
-          <a:srcRect l="0" r="0" t="0" b="0"/>
+          <a:blip r:embed="rId3"/>
+          <a:srcRect/>
           <a:stretch/>
         </p:blipFill>
         <p:spPr>
@@ -4480,7 +4366,7 @@
           <a:bodyPr wrap="square" rtlCol="0" anchor="ctr"/>
           <a:lstStyle/>
           <a:p>
-            <a:pPr algn="ctr" indent="0" marL="0">
+            <a:pPr marL="0" indent="0" algn="ctr">
               <a:buNone/>
             </a:pPr>
             <a:r>
@@ -4514,6 +4400,7 @@
         <a:solidFill>
           <a:srgbClr val="F4F6FB"/>
         </a:solidFill>
+        <a:effectLst/>
       </p:bgPr>
     </p:bg>
     <p:spTree>
@@ -4551,7 +4438,7 @@
           <a:bodyPr wrap="square" rtlCol="0" anchor="ctr"/>
           <a:lstStyle/>
           <a:p>
-            <a:pPr indent="0" marL="0">
+            <a:pPr marL="0" indent="0">
               <a:buNone/>
             </a:pPr>
             <a:r>
@@ -4571,15 +4458,15 @@
       </p:sp>
       <p:pic>
         <p:nvPicPr>
-          <p:cNvPr id="3" name="Image 0" descr="/home/claude/corr_kpis.png">    </p:cNvPr>
+          <p:cNvPr id="3" name="Image 0" descr="/home/claude/corr_kpis.png"/>
           <p:cNvPicPr>
             <a:picLocks noChangeAspect="1"/>
           </p:cNvPicPr>
           <p:nvPr/>
         </p:nvPicPr>
         <p:blipFill>
-          <a:blip r:embed="rId1"/>
-          <a:srcRect l="0" r="0" t="0" b="0"/>
+          <a:blip r:embed="rId3"/>
+          <a:srcRect/>
           <a:stretch/>
         </p:blipFill>
         <p:spPr>
@@ -4613,13 +4500,20 @@
           </a:solidFill>
           <a:ln/>
           <a:effectLst>
-            <a:outerShdw sx="100000" sy="100000" kx="0" ky="0" algn="bl" rotWithShape="0" blurRad="101600" dist="38100" dir="2700000">
+            <a:outerShdw blurRad="101600" dist="38100" dir="2700000" algn="bl" rotWithShape="0">
               <a:srgbClr val="000000">
                 <a:alpha val="12000"/>
               </a:srgbClr>
             </a:outerShdw>
           </a:effectLst>
         </p:spPr>
+        <p:txBody>
+          <a:bodyPr/>
+          <a:lstStyle/>
+          <a:p>
+            <a:endParaRPr lang="es-ES"/>
+          </a:p>
+        </p:txBody>
       </p:sp>
       <p:sp>
         <p:nvSpPr>
@@ -4642,7 +4536,7 @@
           <a:bodyPr wrap="square" rtlCol="0" anchor="ctr"/>
           <a:lstStyle/>
           <a:p>
-            <a:pPr indent="0" marL="0">
+            <a:pPr marL="0" indent="0">
               <a:buNone/>
             </a:pPr>
             <a:r>
@@ -4681,7 +4575,7 @@
           <a:bodyPr wrap="square" rtlCol="0" anchor="ctr"/>
           <a:lstStyle/>
           <a:p>
-            <a:pPr indent="0" marL="0">
+            <a:pPr marL="0" indent="0">
               <a:buNone/>
             </a:pPr>
             <a:r>
@@ -4720,13 +4614,20 @@
           </a:solidFill>
           <a:ln/>
           <a:effectLst>
-            <a:outerShdw sx="100000" sy="100000" kx="0" ky="0" algn="bl" rotWithShape="0" blurRad="101600" dist="38100" dir="2700000">
+            <a:outerShdw blurRad="101600" dist="38100" dir="2700000" algn="bl" rotWithShape="0">
               <a:srgbClr val="000000">
                 <a:alpha val="12000"/>
               </a:srgbClr>
             </a:outerShdw>
           </a:effectLst>
         </p:spPr>
+        <p:txBody>
+          <a:bodyPr/>
+          <a:lstStyle/>
+          <a:p>
+            <a:endParaRPr lang="es-ES"/>
+          </a:p>
+        </p:txBody>
       </p:sp>
       <p:sp>
         <p:nvSpPr>
@@ -4749,7 +4650,7 @@
           <a:bodyPr wrap="square" rtlCol="0" anchor="ctr"/>
           <a:lstStyle/>
           <a:p>
-            <a:pPr indent="0" marL="0">
+            <a:pPr marL="0" indent="0">
               <a:buNone/>
             </a:pPr>
             <a:r>
@@ -4788,7 +4689,7 @@
           <a:bodyPr wrap="square" rtlCol="0" anchor="ctr"/>
           <a:lstStyle/>
           <a:p>
-            <a:pPr indent="0" marL="0">
+            <a:pPr marL="0" indent="0">
               <a:buNone/>
             </a:pPr>
             <a:r>
@@ -4827,13 +4728,20 @@
           </a:solidFill>
           <a:ln/>
           <a:effectLst>
-            <a:outerShdw sx="100000" sy="100000" kx="0" ky="0" algn="bl" rotWithShape="0" blurRad="101600" dist="38100" dir="2700000">
+            <a:outerShdw blurRad="101600" dist="38100" dir="2700000" algn="bl" rotWithShape="0">
               <a:srgbClr val="000000">
                 <a:alpha val="12000"/>
               </a:srgbClr>
             </a:outerShdw>
           </a:effectLst>
         </p:spPr>
+        <p:txBody>
+          <a:bodyPr/>
+          <a:lstStyle/>
+          <a:p>
+            <a:endParaRPr lang="es-ES"/>
+          </a:p>
+        </p:txBody>
       </p:sp>
       <p:sp>
         <p:nvSpPr>
@@ -4856,7 +4764,7 @@
           <a:bodyPr wrap="square" rtlCol="0" anchor="ctr"/>
           <a:lstStyle/>
           <a:p>
-            <a:pPr indent="0" marL="0">
+            <a:pPr marL="0" indent="0">
               <a:buNone/>
             </a:pPr>
             <a:r>
@@ -4895,7 +4803,7 @@
           <a:bodyPr wrap="square" rtlCol="0" anchor="ctr"/>
           <a:lstStyle/>
           <a:p>
-            <a:pPr indent="0" marL="0">
+            <a:pPr marL="0" indent="0">
               <a:buNone/>
             </a:pPr>
             <a:r>
@@ -4934,13 +4842,20 @@
           </a:solidFill>
           <a:ln/>
           <a:effectLst>
-            <a:outerShdw sx="100000" sy="100000" kx="0" ky="0" algn="bl" rotWithShape="0" blurRad="101600" dist="38100" dir="2700000">
+            <a:outerShdw blurRad="101600" dist="38100" dir="2700000" algn="bl" rotWithShape="0">
               <a:srgbClr val="000000">
                 <a:alpha val="12000"/>
               </a:srgbClr>
             </a:outerShdw>
           </a:effectLst>
         </p:spPr>
+        <p:txBody>
+          <a:bodyPr/>
+          <a:lstStyle/>
+          <a:p>
+            <a:endParaRPr lang="es-ES"/>
+          </a:p>
+        </p:txBody>
       </p:sp>
       <p:sp>
         <p:nvSpPr>
@@ -4963,7 +4878,7 @@
           <a:bodyPr wrap="square" rtlCol="0" anchor="ctr"/>
           <a:lstStyle/>
           <a:p>
-            <a:pPr indent="0" marL="0">
+            <a:pPr marL="0" indent="0">
               <a:buNone/>
             </a:pPr>
             <a:r>
@@ -5002,7 +4917,7 @@
           <a:bodyPr wrap="square" rtlCol="0" anchor="ctr"/>
           <a:lstStyle/>
           <a:p>
-            <a:pPr indent="0" marL="0">
+            <a:pPr marL="0" indent="0">
               <a:buNone/>
             </a:pPr>
             <a:r>
@@ -5036,6 +4951,7 @@
         <a:solidFill>
           <a:srgbClr val="F4F6FB"/>
         </a:solidFill>
+        <a:effectLst/>
       </p:bgPr>
     </p:bg>
     <p:spTree>
@@ -5073,7 +4989,7 @@
           <a:bodyPr wrap="square" rtlCol="0" anchor="ctr"/>
           <a:lstStyle/>
           <a:p>
-            <a:pPr indent="0" marL="0">
+            <a:pPr marL="0" indent="0">
               <a:buNone/>
             </a:pPr>
             <a:r>
@@ -5093,15 +5009,15 @@
       </p:sp>
       <p:pic>
         <p:nvPicPr>
-          <p:cNvPr id="3" name="Image 0" descr="/home/claude/metodo_codo.png">    </p:cNvPr>
+          <p:cNvPr id="3" name="Image 0" descr="/home/claude/metodo_codo.png"/>
           <p:cNvPicPr>
             <a:picLocks noChangeAspect="1"/>
           </p:cNvPicPr>
           <p:nvPr/>
         </p:nvPicPr>
         <p:blipFill>
-          <a:blip r:embed="rId1"/>
-          <a:srcRect l="0" r="0" t="0" b="0"/>
+          <a:blip r:embed="rId3"/>
+          <a:srcRect/>
           <a:stretch/>
         </p:blipFill>
         <p:spPr>
@@ -5135,13 +5051,20 @@
           </a:solidFill>
           <a:ln/>
           <a:effectLst>
-            <a:outerShdw sx="100000" sy="100000" kx="0" ky="0" algn="bl" rotWithShape="0" blurRad="101600" dist="38100" dir="2700000">
+            <a:outerShdw blurRad="101600" dist="38100" dir="2700000" algn="bl" rotWithShape="0">
               <a:srgbClr val="000000">
                 <a:alpha val="12000"/>
               </a:srgbClr>
             </a:outerShdw>
           </a:effectLst>
         </p:spPr>
+        <p:txBody>
+          <a:bodyPr/>
+          <a:lstStyle/>
+          <a:p>
+            <a:endParaRPr lang="es-ES"/>
+          </a:p>
+        </p:txBody>
       </p:sp>
       <p:sp>
         <p:nvSpPr>
@@ -5164,7 +5087,7 @@
           <a:bodyPr wrap="square" rtlCol="0" anchor="ctr"/>
           <a:lstStyle/>
           <a:p>
-            <a:pPr algn="ctr" indent="0" marL="0">
+            <a:pPr marL="0" indent="0" algn="ctr">
               <a:buNone/>
             </a:pPr>
             <a:r>
@@ -5304,6 +5227,7 @@
         <a:solidFill>
           <a:srgbClr val="F4F6FB"/>
         </a:solidFill>
+        <a:effectLst/>
       </p:bgPr>
     </p:bg>
     <p:spTree>
@@ -5341,7 +5265,7 @@
           <a:bodyPr wrap="square" rtlCol="0" anchor="ctr"/>
           <a:lstStyle/>
           <a:p>
-            <a:pPr indent="0" marL="0">
+            <a:pPr marL="0" indent="0">
               <a:buNone/>
             </a:pPr>
             <a:r>
@@ -5361,15 +5285,15 @@
       </p:sp>
       <p:pic>
         <p:nvPicPr>
-          <p:cNvPr id="3" name="Image 0" descr="/home/claude/kmeans_pca.png">    </p:cNvPr>
+          <p:cNvPr id="3" name="Image 0" descr="/home/claude/kmeans_pca.png"/>
           <p:cNvPicPr>
             <a:picLocks noChangeAspect="1"/>
           </p:cNvPicPr>
           <p:nvPr/>
         </p:nvPicPr>
         <p:blipFill>
-          <a:blip r:embed="rId1"/>
-          <a:srcRect l="0" r="0" t="0" b="0"/>
+          <a:blip r:embed="rId3"/>
+          <a:srcRect/>
           <a:stretch/>
         </p:blipFill>
         <p:spPr>
@@ -5403,13 +5327,20 @@
           </a:solidFill>
           <a:ln/>
           <a:effectLst>
-            <a:outerShdw sx="100000" sy="100000" kx="0" ky="0" algn="bl" rotWithShape="0" blurRad="101600" dist="38100" dir="2700000">
+            <a:outerShdw blurRad="101600" dist="38100" dir="2700000" algn="bl" rotWithShape="0">
               <a:srgbClr val="000000">
                 <a:alpha val="12000"/>
               </a:srgbClr>
             </a:outerShdw>
           </a:effectLst>
         </p:spPr>
+        <p:txBody>
+          <a:bodyPr/>
+          <a:lstStyle/>
+          <a:p>
+            <a:endParaRPr lang="es-ES"/>
+          </a:p>
+        </p:txBody>
       </p:sp>
       <p:sp>
         <p:nvSpPr>
@@ -5432,7 +5363,7 @@
           <a:bodyPr wrap="square" rtlCol="0" anchor="ctr"/>
           <a:lstStyle/>
           <a:p>
-            <a:pPr indent="0" marL="0">
+            <a:pPr marL="0" indent="0">
               <a:buNone/>
             </a:pPr>
             <a:r>
@@ -5471,7 +5402,7 @@
           <a:bodyPr wrap="square" rtlCol="0" anchor="ctr"/>
           <a:lstStyle/>
           <a:p>
-            <a:pPr indent="0" marL="0">
+            <a:pPr marL="0" indent="0">
               <a:buNone/>
             </a:pPr>
             <a:r>
@@ -5488,7 +5419,7 @@
             <a:endParaRPr lang="en-US" sz="1100" dirty="0"/>
           </a:p>
           <a:p>
-            <a:pPr indent="0" marL="0">
+            <a:pPr marL="0" indent="0">
               <a:buNone/>
             </a:pPr>
             <a:r>
@@ -5527,13 +5458,20 @@
           </a:solidFill>
           <a:ln/>
           <a:effectLst>
-            <a:outerShdw sx="100000" sy="100000" kx="0" ky="0" algn="bl" rotWithShape="0" blurRad="101600" dist="38100" dir="2700000">
+            <a:outerShdw blurRad="101600" dist="38100" dir="2700000" algn="bl" rotWithShape="0">
               <a:srgbClr val="000000">
                 <a:alpha val="12000"/>
               </a:srgbClr>
             </a:outerShdw>
           </a:effectLst>
         </p:spPr>
+        <p:txBody>
+          <a:bodyPr/>
+          <a:lstStyle/>
+          <a:p>
+            <a:endParaRPr lang="es-ES"/>
+          </a:p>
+        </p:txBody>
       </p:sp>
       <p:sp>
         <p:nvSpPr>
@@ -5556,7 +5494,7 @@
           <a:bodyPr wrap="square" rtlCol="0" anchor="ctr"/>
           <a:lstStyle/>
           <a:p>
-            <a:pPr indent="0" marL="0">
+            <a:pPr marL="0" indent="0">
               <a:buNone/>
             </a:pPr>
             <a:r>
@@ -5595,7 +5533,7 @@
           <a:bodyPr wrap="square" rtlCol="0" anchor="ctr"/>
           <a:lstStyle/>
           <a:p>
-            <a:pPr indent="0" marL="0">
+            <a:pPr marL="0" indent="0">
               <a:buNone/>
             </a:pPr>
             <a:r>
@@ -5612,7 +5550,7 @@
             <a:endParaRPr lang="en-US" sz="1100" dirty="0"/>
           </a:p>
           <a:p>
-            <a:pPr indent="0" marL="0">
+            <a:pPr marL="0" indent="0">
               <a:buNone/>
             </a:pPr>
             <a:r>
@@ -5651,13 +5589,20 @@
           </a:solidFill>
           <a:ln/>
           <a:effectLst>
-            <a:outerShdw sx="100000" sy="100000" kx="0" ky="0" algn="bl" rotWithShape="0" blurRad="101600" dist="38100" dir="2700000">
+            <a:outerShdw blurRad="101600" dist="38100" dir="2700000" algn="bl" rotWithShape="0">
               <a:srgbClr val="000000">
                 <a:alpha val="12000"/>
               </a:srgbClr>
             </a:outerShdw>
           </a:effectLst>
         </p:spPr>
+        <p:txBody>
+          <a:bodyPr/>
+          <a:lstStyle/>
+          <a:p>
+            <a:endParaRPr lang="es-ES"/>
+          </a:p>
+        </p:txBody>
       </p:sp>
       <p:sp>
         <p:nvSpPr>
@@ -5680,7 +5625,7 @@
           <a:bodyPr wrap="square" rtlCol="0" anchor="ctr"/>
           <a:lstStyle/>
           <a:p>
-            <a:pPr indent="0" marL="0">
+            <a:pPr marL="0" indent="0">
               <a:buNone/>
             </a:pPr>
             <a:r>
@@ -5719,7 +5664,7 @@
           <a:bodyPr wrap="square" rtlCol="0" anchor="ctr"/>
           <a:lstStyle/>
           <a:p>
-            <a:pPr indent="0" marL="0">
+            <a:pPr marL="0" indent="0">
               <a:buNone/>
             </a:pPr>
             <a:r>
@@ -5736,7 +5681,7 @@
             <a:endParaRPr lang="en-US" sz="1100" dirty="0"/>
           </a:p>
           <a:p>
-            <a:pPr indent="0" marL="0">
+            <a:pPr marL="0" indent="0">
               <a:buNone/>
             </a:pPr>
             <a:r>
@@ -5775,13 +5720,20 @@
           </a:solidFill>
           <a:ln/>
           <a:effectLst>
-            <a:outerShdw sx="100000" sy="100000" kx="0" ky="0" algn="bl" rotWithShape="0" blurRad="101600" dist="38100" dir="2700000">
+            <a:outerShdw blurRad="101600" dist="38100" dir="2700000" algn="bl" rotWithShape="0">
               <a:srgbClr val="000000">
                 <a:alpha val="12000"/>
               </a:srgbClr>
             </a:outerShdw>
           </a:effectLst>
         </p:spPr>
+        <p:txBody>
+          <a:bodyPr/>
+          <a:lstStyle/>
+          <a:p>
+            <a:endParaRPr lang="es-ES"/>
+          </a:p>
+        </p:txBody>
       </p:sp>
       <p:sp>
         <p:nvSpPr>
@@ -5804,7 +5756,7 @@
           <a:bodyPr wrap="square" rtlCol="0" anchor="ctr"/>
           <a:lstStyle/>
           <a:p>
-            <a:pPr indent="0" marL="0">
+            <a:pPr marL="0" indent="0">
               <a:buNone/>
             </a:pPr>
             <a:r>
@@ -5843,7 +5795,7 @@
           <a:bodyPr wrap="square" rtlCol="0" anchor="ctr"/>
           <a:lstStyle/>
           <a:p>
-            <a:pPr indent="0" marL="0">
+            <a:pPr marL="0" indent="0">
               <a:buNone/>
             </a:pPr>
             <a:r>
@@ -5860,7 +5812,7 @@
             <a:endParaRPr lang="en-US" sz="1100" dirty="0"/>
           </a:p>
           <a:p>
-            <a:pPr indent="0" marL="0">
+            <a:pPr marL="0" indent="0">
               <a:buNone/>
             </a:pPr>
             <a:r>
@@ -5894,6 +5846,7 @@
         <a:solidFill>
           <a:srgbClr val="F4F6FB"/>
         </a:solidFill>
+        <a:effectLst/>
       </p:bgPr>
     </p:bg>
     <p:spTree>
@@ -5931,7 +5884,7 @@
           <a:bodyPr wrap="square" rtlCol="0" anchor="ctr"/>
           <a:lstStyle/>
           <a:p>
-            <a:pPr indent="0" marL="0">
+            <a:pPr marL="0" indent="0">
               <a:buNone/>
             </a:pPr>
             <a:r>
@@ -5951,15 +5904,15 @@
       </p:sp>
       <p:pic>
         <p:nvPicPr>
-          <p:cNvPr id="3" name="Image 0" descr="/home/claude/dashboard1.png">    </p:cNvPr>
+          <p:cNvPr id="3" name="Image 0" descr="/home/claude/dashboard1.png"/>
           <p:cNvPicPr>
             <a:picLocks noChangeAspect="1"/>
           </p:cNvPicPr>
           <p:nvPr/>
         </p:nvPicPr>
         <p:blipFill>
-          <a:blip r:embed="rId1"/>
-          <a:srcRect l="0" r="0" t="0" b="0"/>
+          <a:blip r:embed="rId3"/>
+          <a:srcRect/>
           <a:stretch/>
         </p:blipFill>
         <p:spPr>
@@ -5993,7 +5946,7 @@
           <a:bodyPr wrap="square" rtlCol="0" anchor="ctr"/>
           <a:lstStyle/>
           <a:p>
-            <a:pPr algn="ctr" indent="0" marL="0">
+            <a:pPr marL="0" indent="0" algn="ctr">
               <a:buNone/>
             </a:pPr>
             <a:r>
@@ -6027,6 +5980,7 @@
         <a:solidFill>
           <a:srgbClr val="F4F6FB"/>
         </a:solidFill>
+        <a:effectLst/>
       </p:bgPr>
     </p:bg>
     <p:spTree>
@@ -6064,7 +6018,7 @@
           <a:bodyPr wrap="square" rtlCol="0" anchor="ctr"/>
           <a:lstStyle/>
           <a:p>
-            <a:pPr indent="0" marL="0">
+            <a:pPr marL="0" indent="0">
               <a:buNone/>
             </a:pPr>
             <a:r>
@@ -6084,15 +6038,15 @@
       </p:sp>
       <p:pic>
         <p:nvPicPr>
-          <p:cNvPr id="3" name="Image 0" descr="/home/claude/dashboard2.png">    </p:cNvPr>
+          <p:cNvPr id="3" name="Image 0" descr="/home/claude/dashboard2.png"/>
           <p:cNvPicPr>
             <a:picLocks noChangeAspect="1"/>
           </p:cNvPicPr>
           <p:nvPr/>
         </p:nvPicPr>
         <p:blipFill>
-          <a:blip r:embed="rId1"/>
-          <a:srcRect l="0" r="0" t="0" b="0"/>
+          <a:blip r:embed="rId3"/>
+          <a:srcRect/>
           <a:stretch/>
         </p:blipFill>
         <p:spPr>
@@ -6126,7 +6080,7 @@
           <a:bodyPr wrap="square" rtlCol="0" anchor="ctr"/>
           <a:lstStyle/>
           <a:p>
-            <a:pPr algn="ctr" indent="0" marL="0">
+            <a:pPr marL="0" indent="0" algn="ctr">
               <a:buNone/>
             </a:pPr>
             <a:r>
@@ -6445,4 +6399,319 @@
     </a:ext>
   </a:extLst>
 </a:theme>
+</file>
+
+<file path=ppt/theme/theme2.xml><?xml version="1.0" encoding="utf-8"?>
+<a:theme xmlns:a="http://schemas.openxmlformats.org/drawingml/2006/main" name="Tema de Office">
+  <a:themeElements>
+    <a:clrScheme name="Office">
+      <a:dk1>
+        <a:sysClr val="windowText" lastClr="000000"/>
+      </a:dk1>
+      <a:lt1>
+        <a:sysClr val="window" lastClr="FFFFFF"/>
+      </a:lt1>
+      <a:dk2>
+        <a:srgbClr val="0E2841"/>
+      </a:dk2>
+      <a:lt2>
+        <a:srgbClr val="E8E8E8"/>
+      </a:lt2>
+      <a:accent1>
+        <a:srgbClr val="156082"/>
+      </a:accent1>
+      <a:accent2>
+        <a:srgbClr val="E97132"/>
+      </a:accent2>
+      <a:accent3>
+        <a:srgbClr val="196B24"/>
+      </a:accent3>
+      <a:accent4>
+        <a:srgbClr val="0F9ED5"/>
+      </a:accent4>
+      <a:accent5>
+        <a:srgbClr val="A02B93"/>
+      </a:accent5>
+      <a:accent6>
+        <a:srgbClr val="4EA72E"/>
+      </a:accent6>
+      <a:hlink>
+        <a:srgbClr val="467886"/>
+      </a:hlink>
+      <a:folHlink>
+        <a:srgbClr val="96607D"/>
+      </a:folHlink>
+    </a:clrScheme>
+    <a:fontScheme name="Office">
+      <a:majorFont>
+        <a:latin typeface="Aptos Display" panose="02110004020202020204"/>
+        <a:ea typeface=""/>
+        <a:cs typeface=""/>
+        <a:font script="Jpan" typeface="游ゴシック Light"/>
+        <a:font script="Hang" typeface="맑은 고딕"/>
+        <a:font script="Hans" typeface="等线 Light"/>
+        <a:font script="Hant" typeface="新細明體"/>
+        <a:font script="Arab" typeface="Times New Roman"/>
+        <a:font script="Hebr" typeface="Times New Roman"/>
+        <a:font script="Thai" typeface="Angsana New"/>
+        <a:font script="Ethi" typeface="Nyala"/>
+        <a:font script="Beng" typeface="Vrinda"/>
+        <a:font script="Gujr" typeface="Shruti"/>
+        <a:font script="Khmr" typeface="MoolBoran"/>
+        <a:font script="Knda" typeface="Tunga"/>
+        <a:font script="Guru" typeface="Raavi"/>
+        <a:font script="Cans" typeface="Euphemia"/>
+        <a:font script="Cher" typeface="Plantagenet Cherokee"/>
+        <a:font script="Yiii" typeface="Microsoft Yi Baiti"/>
+        <a:font script="Tibt" typeface="Microsoft Himalaya"/>
+        <a:font script="Thaa" typeface="MV Boli"/>
+        <a:font script="Deva" typeface="Mangal"/>
+        <a:font script="Telu" typeface="Gautami"/>
+        <a:font script="Taml" typeface="Latha"/>
+        <a:font script="Syrc" typeface="Estrangelo Edessa"/>
+        <a:font script="Orya" typeface="Kalinga"/>
+        <a:font script="Mlym" typeface="Kartika"/>
+        <a:font script="Laoo" typeface="DokChampa"/>
+        <a:font script="Sinh" typeface="Iskoola Pota"/>
+        <a:font script="Mong" typeface="Mongolian Baiti"/>
+        <a:font script="Viet" typeface="Times New Roman"/>
+        <a:font script="Uigh" typeface="Microsoft Uighur"/>
+        <a:font script="Geor" typeface="Sylfaen"/>
+        <a:font script="Armn" typeface="Arial"/>
+        <a:font script="Bugi" typeface="Leelawadee UI"/>
+        <a:font script="Bopo" typeface="Microsoft JhengHei"/>
+        <a:font script="Java" typeface="Javanese Text"/>
+        <a:font script="Lisu" typeface="Segoe UI"/>
+        <a:font script="Mymr" typeface="Myanmar Text"/>
+        <a:font script="Nkoo" typeface="Ebrima"/>
+        <a:font script="Olck" typeface="Nirmala UI"/>
+        <a:font script="Osma" typeface="Ebrima"/>
+        <a:font script="Phag" typeface="Phagspa"/>
+        <a:font script="Syrn" typeface="Estrangelo Edessa"/>
+        <a:font script="Syrj" typeface="Estrangelo Edessa"/>
+        <a:font script="Syre" typeface="Estrangelo Edessa"/>
+        <a:font script="Sora" typeface="Nirmala UI"/>
+        <a:font script="Tale" typeface="Microsoft Tai Le"/>
+        <a:font script="Talu" typeface="Microsoft New Tai Lue"/>
+        <a:font script="Tfng" typeface="Ebrima"/>
+      </a:majorFont>
+      <a:minorFont>
+        <a:latin typeface="Aptos" panose="02110004020202020204"/>
+        <a:ea typeface=""/>
+        <a:cs typeface=""/>
+        <a:font script="Jpan" typeface="游ゴシック"/>
+        <a:font script="Hang" typeface="맑은 고딕"/>
+        <a:font script="Hans" typeface="等线"/>
+        <a:font script="Hant" typeface="新細明體"/>
+        <a:font script="Arab" typeface="Arial"/>
+        <a:font script="Hebr" typeface="Arial"/>
+        <a:font script="Thai" typeface="Cordia New"/>
+        <a:font script="Ethi" typeface="Nyala"/>
+        <a:font script="Beng" typeface="Vrinda"/>
+        <a:font script="Gujr" typeface="Shruti"/>
+        <a:font script="Khmr" typeface="DaunPenh"/>
+        <a:font script="Knda" typeface="Tunga"/>
+        <a:font script="Guru" typeface="Raavi"/>
+        <a:font script="Cans" typeface="Euphemia"/>
+        <a:font script="Cher" typeface="Plantagenet Cherokee"/>
+        <a:font script="Yiii" typeface="Microsoft Yi Baiti"/>
+        <a:font script="Tibt" typeface="Microsoft Himalaya"/>
+        <a:font script="Thaa" typeface="MV Boli"/>
+        <a:font script="Deva" typeface="Mangal"/>
+        <a:font script="Telu" typeface="Gautami"/>
+        <a:font script="Taml" typeface="Latha"/>
+        <a:font script="Syrc" typeface="Estrangelo Edessa"/>
+        <a:font script="Orya" typeface="Kalinga"/>
+        <a:font script="Mlym" typeface="Kartika"/>
+        <a:font script="Laoo" typeface="DokChampa"/>
+        <a:font script="Sinh" typeface="Iskoola Pota"/>
+        <a:font script="Mong" typeface="Mongolian Baiti"/>
+        <a:font script="Viet" typeface="Arial"/>
+        <a:font script="Uigh" typeface="Microsoft Uighur"/>
+        <a:font script="Geor" typeface="Sylfaen"/>
+        <a:font script="Armn" typeface="Arial"/>
+        <a:font script="Bugi" typeface="Leelawadee UI"/>
+        <a:font script="Bopo" typeface="Microsoft JhengHei"/>
+        <a:font script="Java" typeface="Javanese Text"/>
+        <a:font script="Lisu" typeface="Segoe UI"/>
+        <a:font script="Mymr" typeface="Myanmar Text"/>
+        <a:font script="Nkoo" typeface="Ebrima"/>
+        <a:font script="Olck" typeface="Nirmala UI"/>
+        <a:font script="Osma" typeface="Ebrima"/>
+        <a:font script="Phag" typeface="Phagspa"/>
+        <a:font script="Syrn" typeface="Estrangelo Edessa"/>
+        <a:font script="Syrj" typeface="Estrangelo Edessa"/>
+        <a:font script="Syre" typeface="Estrangelo Edessa"/>
+        <a:font script="Sora" typeface="Nirmala UI"/>
+        <a:font script="Tale" typeface="Microsoft Tai Le"/>
+        <a:font script="Talu" typeface="Microsoft New Tai Lue"/>
+        <a:font script="Tfng" typeface="Ebrima"/>
+      </a:minorFont>
+    </a:fontScheme>
+    <a:fmtScheme name="Office">
+      <a:fillStyleLst>
+        <a:solidFill>
+          <a:schemeClr val="phClr"/>
+        </a:solidFill>
+        <a:gradFill rotWithShape="1">
+          <a:gsLst>
+            <a:gs pos="0">
+              <a:schemeClr val="phClr">
+                <a:lumMod val="110000"/>
+                <a:satMod val="105000"/>
+                <a:tint val="67000"/>
+              </a:schemeClr>
+            </a:gs>
+            <a:gs pos="50000">
+              <a:schemeClr val="phClr">
+                <a:lumMod val="105000"/>
+                <a:satMod val="103000"/>
+                <a:tint val="73000"/>
+              </a:schemeClr>
+            </a:gs>
+            <a:gs pos="100000">
+              <a:schemeClr val="phClr">
+                <a:lumMod val="105000"/>
+                <a:satMod val="109000"/>
+                <a:tint val="81000"/>
+              </a:schemeClr>
+            </a:gs>
+          </a:gsLst>
+          <a:lin ang="5400000" scaled="0"/>
+        </a:gradFill>
+        <a:gradFill rotWithShape="1">
+          <a:gsLst>
+            <a:gs pos="0">
+              <a:schemeClr val="phClr">
+                <a:satMod val="103000"/>
+                <a:lumMod val="102000"/>
+                <a:tint val="94000"/>
+              </a:schemeClr>
+            </a:gs>
+            <a:gs pos="50000">
+              <a:schemeClr val="phClr">
+                <a:satMod val="110000"/>
+                <a:lumMod val="100000"/>
+                <a:shade val="100000"/>
+              </a:schemeClr>
+            </a:gs>
+            <a:gs pos="100000">
+              <a:schemeClr val="phClr">
+                <a:lumMod val="99000"/>
+                <a:satMod val="120000"/>
+                <a:shade val="78000"/>
+              </a:schemeClr>
+            </a:gs>
+          </a:gsLst>
+          <a:lin ang="5400000" scaled="0"/>
+        </a:gradFill>
+      </a:fillStyleLst>
+      <a:lnStyleLst>
+        <a:ln w="12700" cap="flat" cmpd="sng" algn="ctr">
+          <a:solidFill>
+            <a:schemeClr val="phClr"/>
+          </a:solidFill>
+          <a:prstDash val="solid"/>
+          <a:miter lim="800000"/>
+        </a:ln>
+        <a:ln w="19050" cap="flat" cmpd="sng" algn="ctr">
+          <a:solidFill>
+            <a:schemeClr val="phClr"/>
+          </a:solidFill>
+          <a:prstDash val="solid"/>
+          <a:miter lim="800000"/>
+        </a:ln>
+        <a:ln w="25400" cap="flat" cmpd="sng" algn="ctr">
+          <a:solidFill>
+            <a:schemeClr val="phClr"/>
+          </a:solidFill>
+          <a:prstDash val="solid"/>
+          <a:miter lim="800000"/>
+        </a:ln>
+      </a:lnStyleLst>
+      <a:effectStyleLst>
+        <a:effectStyle>
+          <a:effectLst/>
+        </a:effectStyle>
+        <a:effectStyle>
+          <a:effectLst/>
+        </a:effectStyle>
+        <a:effectStyle>
+          <a:effectLst>
+            <a:outerShdw blurRad="57150" dist="19050" dir="5400000" algn="ctr" rotWithShape="0">
+              <a:srgbClr val="000000">
+                <a:alpha val="63000"/>
+              </a:srgbClr>
+            </a:outerShdw>
+          </a:effectLst>
+        </a:effectStyle>
+      </a:effectStyleLst>
+      <a:bgFillStyleLst>
+        <a:solidFill>
+          <a:schemeClr val="phClr"/>
+        </a:solidFill>
+        <a:solidFill>
+          <a:schemeClr val="phClr">
+            <a:tint val="95000"/>
+            <a:satMod val="170000"/>
+          </a:schemeClr>
+        </a:solidFill>
+        <a:gradFill rotWithShape="1">
+          <a:gsLst>
+            <a:gs pos="0">
+              <a:schemeClr val="phClr">
+                <a:tint val="93000"/>
+                <a:satMod val="150000"/>
+                <a:shade val="98000"/>
+                <a:lumMod val="102000"/>
+              </a:schemeClr>
+            </a:gs>
+            <a:gs pos="50000">
+              <a:schemeClr val="phClr">
+                <a:tint val="98000"/>
+                <a:satMod val="130000"/>
+                <a:shade val="90000"/>
+                <a:lumMod val="103000"/>
+              </a:schemeClr>
+            </a:gs>
+            <a:gs pos="100000">
+              <a:schemeClr val="phClr">
+                <a:shade val="63000"/>
+                <a:satMod val="120000"/>
+              </a:schemeClr>
+            </a:gs>
+          </a:gsLst>
+          <a:lin ang="5400000" scaled="0"/>
+        </a:gradFill>
+      </a:bgFillStyleLst>
+    </a:fmtScheme>
+  </a:themeElements>
+  <a:objectDefaults>
+    <a:lnDef>
+      <a:spPr/>
+      <a:bodyPr/>
+      <a:lstStyle/>
+      <a:style>
+        <a:lnRef idx="2">
+          <a:schemeClr val="accent1"/>
+        </a:lnRef>
+        <a:fillRef idx="0">
+          <a:schemeClr val="accent1"/>
+        </a:fillRef>
+        <a:effectRef idx="1">
+          <a:schemeClr val="accent1"/>
+        </a:effectRef>
+        <a:fontRef idx="minor">
+          <a:schemeClr val="tx1"/>
+        </a:fontRef>
+      </a:style>
+    </a:lnDef>
+  </a:objectDefaults>
+  <a:extraClrSchemeLst/>
+  <a:extLst>
+    <a:ext uri="{05A4C25C-085E-4340-85A3-A5531E510DB2}">
+      <thm15:themeFamily xmlns:thm15="http://schemas.microsoft.com/office/thememl/2012/main" name="Office Theme" id="{2E142A2C-CD16-42D6-873A-C26D2A0506FA}" vid="{1BDDFF52-6CD6-40A5-AB3C-68EB2F1E4D0A}"/>
+    </a:ext>
+  </a:extLst>
+</a:theme>
 </file>
</xml_diff>